<commit_message>
TONIGHT: 汇报材料硬化——数字口径统一 180→233 与 PDF 固化。①make_presentation.py 口径源注与 S7 卡片改 233/233（EVAL 用例全过（v2 资产收敛）·8 套件），docstring 注明 v1 180 已作废、对齐 specs-v2/README.md:59 实跑基线 cases=233/233；②DEMO-SCRIPT.md 收尾话术同步 233/233；③presentation.pptx 重新生成（16 页，生成侧隔离字样自检 CLEAN）；④新增 presentation.pdf（LibreOffice headless 转换，投影兜底）。校验：重开 pptx 16 页+S7 卡片文本确认；重转 PDF 后 PyMuPDF 全文扫描 0 越界/0 小字号(<8.5pt)/0 文本块重叠；S7 页视觉复审卡片完整无溢出；门禁 python run_evals.py --module all = 233/233 PASS isolation=OK exit 0（本轮实跑）；交互冒烟 printf 回车步进 --flow f2 与 --flow all --auto 均 exit 0。备份：仓库外 demo-backup-20260930.zip（pptx+PDF+DEMO-SCRIPT+CASE-BACKGROUND+transcript-auto+run_demo.py 等 10 文件，run_demo.py 与仓库 sha256 逐字节一致 273da351…，zip 完整性 OK）。
</commit_message>
<xml_diff>
--- a/docs/presentation/presentation.pptx
+++ b/docs/presentation/presentation.pptx
@@ -3991,7 +3991,7 @@
                 <a:ea typeface="微软雅黑"/>
                 <a:cs typeface="微软雅黑"/>
               </a:rPr>
-              <a:t>　　现场命令：python demo/run_demo.py f1</a:t>
+              <a:t>　　现场命令：python demo/run_demo.py --flow f1</a:t>
             </a:r>
           </a:p>
         </p:txBody>
@@ -4954,7 +4954,7 @@
                 <a:ea typeface="微软雅黑"/>
                 <a:cs typeface="微软雅黑"/>
               </a:rPr>
-              <a:t>　　现场命令：python demo/run_demo.py f2</a:t>
+              <a:t>　　现场命令：python demo/run_demo.py --flow f2</a:t>
             </a:r>
           </a:p>
         </p:txBody>
@@ -5429,7 +5429,7 @@
                 <a:ea typeface="微软雅黑"/>
                 <a:cs typeface="微软雅黑"/>
               </a:rPr>
-              <a:t>　　现场命令：python demo/run_demo.py f3</a:t>
+              <a:t>　　现场命令：python demo/run_demo.py --flow f3</a:t>
             </a:r>
           </a:p>
         </p:txBody>
@@ -5904,7 +5904,7 @@
                 <a:ea typeface="微软雅黑"/>
                 <a:cs typeface="微软雅黑"/>
               </a:rPr>
-              <a:t>　　现场命令：python demo/run_demo.py f4</a:t>
+              <a:t>　　现场命令：python demo/run_demo.py --flow f4</a:t>
             </a:r>
           </a:p>
         </p:txBody>
@@ -7229,7 +7229,7 @@
                 <a:ea typeface="微软雅黑"/>
                 <a:cs typeface="微软雅黑"/>
               </a:rPr>
-              <a:t>python demo/run_demo.py f1 | f2 | f3 | f4 | all</a:t>
+              <a:t>python demo/run_demo.py --flow f1|f2|f3|f4|all</a:t>
             </a:r>
           </a:p>
           <a:p>
@@ -11156,7 +11156,7 @@
                 <a:ea typeface="微软雅黑"/>
                 <a:cs typeface="微软雅黑"/>
               </a:rPr>
-              <a:t>180/180</a:t>
+              <a:t>233/233</a:t>
             </a:r>
           </a:p>
           <a:p>
@@ -11170,7 +11170,7 @@
                 <a:ea typeface="微软雅黑"/>
                 <a:cs typeface="微软雅黑"/>
               </a:rPr>
-              <a:t>EVAL 用例全过
+              <a:t>EVAL 用例全过（v2 资产收敛）
 8 套件 · 正例＋负例 · YAML 数据驱动</a:t>
             </a:r>
           </a:p>
@@ -12496,8 +12496,8 @@
           <p:nvPr/>
         </p:nvGraphicFramePr>
         <p:xfrm>
-          <a:off x="640080" y="2331720"/>
-          <a:ext cx="10927080" cy="2834640"/>
+          <a:off x="640080" y="2267712"/>
+          <a:ext cx="10927080" cy="3054096"/>
         </p:xfrm>
         <a:graphic>
           <a:graphicData uri="http://schemas.openxmlformats.org/drawingml/2006/table">
@@ -12510,7 +12510,7 @@
                 <a:gridCol w="7086600"/>
                 <a:gridCol w="1463040"/>
               </a:tblGrid>
-              <a:tr h="566928">
+              <a:tr h="509016">
                 <a:tc>
                   <a:txBody>
                     <a:bodyPr/>
@@ -12584,7 +12584,7 @@
                   </a:tcPr>
                 </a:tc>
               </a:tr>
-              <a:tr h="566928">
+              <a:tr h="509016">
                 <a:tc>
                   <a:txBody>
                     <a:bodyPr/>
@@ -12658,7 +12658,7 @@
                   </a:tcPr>
                 </a:tc>
               </a:tr>
-              <a:tr h="566928">
+              <a:tr h="509016">
                 <a:tc>
                   <a:txBody>
                     <a:bodyPr/>
@@ -12732,7 +12732,7 @@
                   </a:tcPr>
                 </a:tc>
               </a:tr>
-              <a:tr h="566928">
+              <a:tr h="509016">
                 <a:tc>
                   <a:txBody>
                     <a:bodyPr/>
@@ -12806,7 +12806,7 @@
                   </a:tcPr>
                 </a:tc>
               </a:tr>
-              <a:tr h="566928">
+              <a:tr h="509016">
                 <a:tc>
                   <a:txBody>
                     <a:bodyPr/>
@@ -12880,6 +12880,80 @@
                   </a:tcPr>
                 </a:tc>
               </a:tr>
+              <a:tr h="509016">
+                <a:tc>
+                  <a:txBody>
+                    <a:bodyPr/>
+                    <a:lstStyle/>
+                    <a:p>
+                      <a:r>
+                        <a:rPr sz="1350" b="1">
+                          <a:solidFill>
+                            <a:srgbClr val="1F3864"/>
+                          </a:solidFill>
+                          <a:latin typeface="微软雅黑"/>
+                          <a:ea typeface="微软雅黑"/>
+                          <a:cs typeface="微软雅黑"/>
+                        </a:rPr>
+                        <a:t>收尾回归</a:t>
+                      </a:r>
+                    </a:p>
+                  </a:txBody>
+                  <a:tcPr anchor="ctr" marL="109728" marR="73152" marT="27432" marB="27432">
+                    <a:solidFill>
+                      <a:srgbClr val="FFFFFF"/>
+                    </a:solidFill>
+                  </a:tcPr>
+                </a:tc>
+                <a:tc>
+                  <a:txBody>
+                    <a:bodyPr/>
+                    <a:lstStyle/>
+                    <a:p>
+                      <a:r>
+                        <a:rPr sz="1350" b="0">
+                          <a:solidFill>
+                            <a:srgbClr val="333333"/>
+                          </a:solidFill>
+                          <a:latin typeface="微软雅黑"/>
+                          <a:ea typeface="微软雅黑"/>
+                          <a:cs typeface="微软雅黑"/>
+                        </a:rPr>
+                        <a:t>12 条开发黄金集 × rel-0001 全绿（pass_rate=1.0 · 97.67/100）＋照读边界声明</a:t>
+                      </a:r>
+                    </a:p>
+                  </a:txBody>
+                  <a:tcPr anchor="ctr" marL="109728" marR="73152" marT="27432" marB="27432">
+                    <a:solidFill>
+                      <a:srgbClr val="FFFFFF"/>
+                    </a:solidFill>
+                  </a:tcPr>
+                </a:tc>
+                <a:tc>
+                  <a:txBody>
+                    <a:bodyPr/>
+                    <a:lstStyle/>
+                    <a:p>
+                      <a:r>
+                        <a:rPr sz="1300" b="0">
+                          <a:solidFill>
+                            <a:srgbClr val="333333"/>
+                          </a:solidFill>
+                          <a:latin typeface="微软雅黑"/>
+                          <a:ea typeface="微软雅黑"/>
+                          <a:cs typeface="微软雅黑"/>
+                        </a:rPr>
+                        <a:t>0.5 min</a:t>
+                      </a:r>
+                    </a:p>
+                  </a:txBody>
+                  <a:tcPr anchor="ctr" marL="109728" marR="73152" marT="27432" marB="27432">
+                    <a:solidFill>
+                      <a:srgbClr val="FFFFFF"/>
+                    </a:solidFill>
+                  </a:tcPr>
+                </a:tc>
+              </a:tr>
             </a:tbl>
           </a:graphicData>
         </a:graphic>
@@ -12892,8 +12966,8 @@
         </p:nvSpPr>
         <p:spPr>
           <a:xfrm>
-            <a:off x="640080" y="5358384"/>
-            <a:ext cx="10927080" cy="365760"/>
+            <a:off x="640080" y="5431536"/>
+            <a:ext cx="10927080" cy="320040"/>
           </a:xfrm>
           <a:prstGeom prst="rect">
             <a:avLst/>
@@ -12929,7 +13003,7 @@
         </p:nvSpPr>
         <p:spPr>
           <a:xfrm>
-            <a:off x="640080" y="5815584"/>
+            <a:off x="640080" y="5833872"/>
             <a:ext cx="10927080" cy="566928"/>
           </a:xfrm>
           <a:prstGeom prst="roundRect">
@@ -12975,7 +13049,7 @@
                 <a:ea typeface="微软雅黑"/>
                 <a:cs typeface="微软雅黑"/>
               </a:rPr>
-              <a:t>四条流对应四类岗位场景：日常巡检 · 事故处置 · 防误操作 · 经营细节。</a:t>
+              <a:t>四条流对应四类岗位场景：日常巡检 · 事故处置 · 防误操作 · 经营细节——收尾回归全绿才收场。</a:t>
             </a:r>
           </a:p>
         </p:txBody>

</xml_diff>